<commit_message>
Revert "Added Updated PPT"
This reverts commit ab7111df1fbfdff3fd510f1fd93cb35f73c1ecaf.
</commit_message>
<xml_diff>
--- a/docs/Clg 2nd review.pptx
+++ b/docs/Clg 2nd review.pptx
@@ -213,7 +213,7 @@
           <a:p>
             <a:fld id="{C1BED7E8-5420-4F73-BA32-34A7030FE7D8}" type="datetimeFigureOut">
               <a:rPr lang="en-US" smtClean="0"/>
-              <a:t>4/8/2026</a:t>
+              <a:t>4/6/2026</a:t>
             </a:fld>
             <a:endParaRPr lang="en-US"/>
           </a:p>
@@ -2091,7 +2091,7 @@
           <a:p>
             <a:fld id="{C198EE3F-C531-4F47-81BE-EB7857D8F039}" type="datetimeFigureOut">
               <a:rPr lang="en-US" smtClean="0"/>
-              <a:t>4/8/2026</a:t>
+              <a:t>4/6/2026</a:t>
             </a:fld>
             <a:endParaRPr lang="en-US"/>
           </a:p>
@@ -2289,7 +2289,7 @@
           <a:p>
             <a:fld id="{C198EE3F-C531-4F47-81BE-EB7857D8F039}" type="datetimeFigureOut">
               <a:rPr lang="en-US" smtClean="0"/>
-              <a:t>4/8/2026</a:t>
+              <a:t>4/6/2026</a:t>
             </a:fld>
             <a:endParaRPr lang="en-US"/>
           </a:p>
@@ -2497,7 +2497,7 @@
           <a:p>
             <a:fld id="{C198EE3F-C531-4F47-81BE-EB7857D8F039}" type="datetimeFigureOut">
               <a:rPr lang="en-US" smtClean="0"/>
-              <a:t>4/8/2026</a:t>
+              <a:t>4/6/2026</a:t>
             </a:fld>
             <a:endParaRPr lang="en-US"/>
           </a:p>
@@ -2695,7 +2695,7 @@
           <a:p>
             <a:fld id="{C198EE3F-C531-4F47-81BE-EB7857D8F039}" type="datetimeFigureOut">
               <a:rPr lang="en-US" smtClean="0"/>
-              <a:t>4/8/2026</a:t>
+              <a:t>4/6/2026</a:t>
             </a:fld>
             <a:endParaRPr lang="en-US"/>
           </a:p>
@@ -2970,7 +2970,7 @@
           <a:p>
             <a:fld id="{C198EE3F-C531-4F47-81BE-EB7857D8F039}" type="datetimeFigureOut">
               <a:rPr lang="en-US" smtClean="0"/>
-              <a:t>4/8/2026</a:t>
+              <a:t>4/6/2026</a:t>
             </a:fld>
             <a:endParaRPr lang="en-US"/>
           </a:p>
@@ -3235,7 +3235,7 @@
           <a:p>
             <a:fld id="{C198EE3F-C531-4F47-81BE-EB7857D8F039}" type="datetimeFigureOut">
               <a:rPr lang="en-US" smtClean="0"/>
-              <a:t>4/8/2026</a:t>
+              <a:t>4/6/2026</a:t>
             </a:fld>
             <a:endParaRPr lang="en-US"/>
           </a:p>
@@ -3647,7 +3647,7 @@
           <a:p>
             <a:fld id="{C198EE3F-C531-4F47-81BE-EB7857D8F039}" type="datetimeFigureOut">
               <a:rPr lang="en-US" smtClean="0"/>
-              <a:t>4/8/2026</a:t>
+              <a:t>4/6/2026</a:t>
             </a:fld>
             <a:endParaRPr lang="en-US"/>
           </a:p>
@@ -3788,7 +3788,7 @@
           <a:p>
             <a:fld id="{C198EE3F-C531-4F47-81BE-EB7857D8F039}" type="datetimeFigureOut">
               <a:rPr lang="en-US" smtClean="0"/>
-              <a:t>4/8/2026</a:t>
+              <a:t>4/6/2026</a:t>
             </a:fld>
             <a:endParaRPr lang="en-US"/>
           </a:p>
@@ -3901,7 +3901,7 @@
           <a:p>
             <a:fld id="{C198EE3F-C531-4F47-81BE-EB7857D8F039}" type="datetimeFigureOut">
               <a:rPr lang="en-US" smtClean="0"/>
-              <a:t>4/8/2026</a:t>
+              <a:t>4/6/2026</a:t>
             </a:fld>
             <a:endParaRPr lang="en-US"/>
           </a:p>
@@ -4212,7 +4212,7 @@
           <a:p>
             <a:fld id="{C198EE3F-C531-4F47-81BE-EB7857D8F039}" type="datetimeFigureOut">
               <a:rPr lang="en-US" smtClean="0"/>
-              <a:t>4/8/2026</a:t>
+              <a:t>4/6/2026</a:t>
             </a:fld>
             <a:endParaRPr lang="en-US"/>
           </a:p>
@@ -4500,7 +4500,7 @@
           <a:p>
             <a:fld id="{C198EE3F-C531-4F47-81BE-EB7857D8F039}" type="datetimeFigureOut">
               <a:rPr lang="en-US" smtClean="0"/>
-              <a:t>4/8/2026</a:t>
+              <a:t>4/6/2026</a:t>
             </a:fld>
             <a:endParaRPr lang="en-US"/>
           </a:p>
@@ -4741,7 +4741,7 @@
           <a:p>
             <a:fld id="{C198EE3F-C531-4F47-81BE-EB7857D8F039}" type="datetimeFigureOut">
               <a:rPr lang="en-US" smtClean="0"/>
-              <a:t>4/8/2026</a:t>
+              <a:t>4/6/2026</a:t>
             </a:fld>
             <a:endParaRPr lang="en-US"/>
           </a:p>
@@ -6722,7 +6722,7 @@
         <p:spPr>
           <a:xfrm>
             <a:off x="265471" y="792624"/>
-            <a:ext cx="11661058" cy="4401205"/>
+            <a:ext cx="11661058" cy="4093428"/>
           </a:xfrm>
           <a:prstGeom prst="rect">
             <a:avLst/>
@@ -6744,7 +6744,7 @@
                 <a:latin typeface="Times New Roman" panose="02020603050405020304" pitchFamily="18" charset="0"/>
                 <a:cs typeface="Times New Roman" panose="02020603050405020304" pitchFamily="18" charset="0"/>
               </a:rPr>
-              <a:t>Proactive Failure Prevention &amp; Asset Longevity: Reduces unexpected breakdowns and significantly increases equipment lifespan by continuously monitoring performance to detect early degradation and predict potential failures in advance.</a:t>
+              <a:t>Reduces unexpected breakdowns by predicting potential failures in advance and enabling timely preventive maintenance actions.</a:t>
             </a:r>
           </a:p>
           <a:p>
@@ -6752,10 +6752,13 @@
               <a:buFont typeface="Wingdings" panose="05000000000000000000" pitchFamily="2" charset="2"/>
               <a:buChar char="Ø"/>
             </a:pPr>
-            <a:endParaRPr lang="en-US" sz="2000" dirty="0">
-              <a:latin typeface="Times New Roman" panose="02020603050405020304" pitchFamily="18" charset="0"/>
-              <a:cs typeface="Times New Roman" panose="02020603050405020304" pitchFamily="18" charset="0"/>
-            </a:endParaRPr>
+            <a:r>
+              <a:rPr lang="en-US" sz="2000" dirty="0">
+                <a:latin typeface="Times New Roman" panose="02020603050405020304" pitchFamily="18" charset="0"/>
+                <a:cs typeface="Times New Roman" panose="02020603050405020304" pitchFamily="18" charset="0"/>
+              </a:rPr>
+              <a:t>Minimizes maintenance costs by shifting from reactive repairs to planned maintenance based on equipment condition.</a:t>
+            </a:r>
           </a:p>
           <a:p>
             <a:pPr marL="342900" indent="-342900" algn="just">
@@ -6767,7 +6770,7 @@
                 <a:latin typeface="Times New Roman" panose="02020603050405020304" pitchFamily="18" charset="0"/>
                 <a:cs typeface="Times New Roman" panose="02020603050405020304" pitchFamily="18" charset="0"/>
               </a:rPr>
-              <a:t>Cost Optimization &amp; Operational Efficiency: Minimizes maintenance costs and improves overall efficiency by shifting from reactive repairs to planned, condition-based maintenance, optimizing schedules, and reducing production downtime.</a:t>
+              <a:t>Increases equipment lifespan through continuous monitoring and early detection of performance degradation.</a:t>
             </a:r>
           </a:p>
           <a:p>
@@ -6775,10 +6778,13 @@
               <a:buFont typeface="Wingdings" panose="05000000000000000000" pitchFamily="2" charset="2"/>
               <a:buChar char="Ø"/>
             </a:pPr>
-            <a:endParaRPr lang="en-US" sz="2000" dirty="0">
-              <a:latin typeface="Times New Roman" panose="02020603050405020304" pitchFamily="18" charset="0"/>
-              <a:cs typeface="Times New Roman" panose="02020603050405020304" pitchFamily="18" charset="0"/>
-            </a:endParaRPr>
+            <a:r>
+              <a:rPr lang="en-US" sz="2000" dirty="0">
+                <a:latin typeface="Times New Roman" panose="02020603050405020304" pitchFamily="18" charset="0"/>
+                <a:cs typeface="Times New Roman" panose="02020603050405020304" pitchFamily="18" charset="0"/>
+              </a:rPr>
+              <a:t>Provides real-time monitoring of equipment health parameters for faster decision-making and operational control.</a:t>
+            </a:r>
           </a:p>
           <a:p>
             <a:pPr marL="342900" indent="-342900" algn="just">
@@ -6790,7 +6796,7 @@
                 <a:latin typeface="Times New Roman" panose="02020603050405020304" pitchFamily="18" charset="0"/>
                 <a:cs typeface="Times New Roman" panose="02020603050405020304" pitchFamily="18" charset="0"/>
               </a:rPr>
-              <a:t>Real-Time Monitoring &amp; Agile Decision-Making: Provides real-time visibility into vital equipment health parameters, enabling faster, data-driven decision-making and enhanced operational control.</a:t>
+              <a:t>Ensures cloud scalability, allowing the system to handle increasing data volume and multiple equipment units efficiently.</a:t>
             </a:r>
           </a:p>
           <a:p>
@@ -6798,10 +6804,13 @@
               <a:buFont typeface="Wingdings" panose="05000000000000000000" pitchFamily="2" charset="2"/>
               <a:buChar char="Ø"/>
             </a:pPr>
-            <a:endParaRPr lang="en-US" sz="2000" dirty="0">
-              <a:latin typeface="Times New Roman" panose="02020603050405020304" pitchFamily="18" charset="0"/>
-              <a:cs typeface="Times New Roman" panose="02020603050405020304" pitchFamily="18" charset="0"/>
-            </a:endParaRPr>
+            <a:r>
+              <a:rPr lang="en-US" sz="2000" dirty="0">
+                <a:latin typeface="Times New Roman" panose="02020603050405020304" pitchFamily="18" charset="0"/>
+                <a:cs typeface="Times New Roman" panose="02020603050405020304" pitchFamily="18" charset="0"/>
+              </a:rPr>
+              <a:t>Offers secure data storage with authentication and controlled access to protect sensitive operational information.</a:t>
+            </a:r>
           </a:p>
           <a:p>
             <a:pPr marL="342900" indent="-342900" algn="just">
@@ -6813,7 +6822,7 @@
                 <a:latin typeface="Times New Roman" panose="02020603050405020304" pitchFamily="18" charset="0"/>
                 <a:cs typeface="Times New Roman" panose="02020603050405020304" pitchFamily="18" charset="0"/>
               </a:rPr>
-              <a:t>Scalable &amp; Secure Cloud Infrastructure: Leverages scalable cloud capabilities to efficiently handle increasing data volumes and multiple equipment units, while protecting sensitive operational information through secure data storage, authentication, and controlled access.</a:t>
+              <a:t>Improves overall operational efficiency by optimizing maintenance scheduling and reducing production downtime.</a:t>
             </a:r>
           </a:p>
         </p:txBody>
@@ -6926,7 +6935,7 @@
                 <a:latin typeface="Times New Roman" panose="02020603050405020304" pitchFamily="18" charset="0"/>
                 <a:cs typeface="Times New Roman" panose="02020603050405020304" pitchFamily="18" charset="0"/>
               </a:rPr>
-              <a:t>Data Quality &amp; Model Reliability: The effectiveness and accuracy of the machine learning model heavily depend on the quality of its training data; accurate, balanced historical data is essential to ensure reliable failure predictions.</a:t>
+              <a:t>Requires accurate historical data to train the machine learning model effectively and ensure reliable failure predictions.</a:t>
             </a:r>
           </a:p>
           <a:p>
@@ -6934,10 +6943,13 @@
               <a:buFont typeface="Wingdings" panose="05000000000000000000" pitchFamily="2" charset="2"/>
               <a:buChar char="Ø"/>
             </a:pPr>
-            <a:endParaRPr lang="en-US" sz="2000" dirty="0">
-              <a:latin typeface="Times New Roman" panose="02020603050405020304" pitchFamily="18" charset="0"/>
-              <a:cs typeface="Times New Roman" panose="02020603050405020304" pitchFamily="18" charset="0"/>
-            </a:endParaRPr>
+            <a:r>
+              <a:rPr lang="en-US" sz="2000" dirty="0">
+                <a:latin typeface="Times New Roman" panose="02020603050405020304" pitchFamily="18" charset="0"/>
+                <a:cs typeface="Times New Roman" panose="02020603050405020304" pitchFamily="18" charset="0"/>
+              </a:rPr>
+              <a:t>Initial setup cost is high, as it involves cloud infrastructure configuration, system development, and model training.</a:t>
+            </a:r>
           </a:p>
           <a:p>
             <a:pPr marL="342900" indent="-342900" algn="just">
@@ -6949,7 +6961,7 @@
                 <a:latin typeface="Times New Roman" panose="02020603050405020304" pitchFamily="18" charset="0"/>
                 <a:cs typeface="Times New Roman" panose="02020603050405020304" pitchFamily="18" charset="0"/>
               </a:rPr>
-              <a:t>High Initial Investment: Implementing the system involves significant upfront costs related to configuring cloud infrastructure, system development, and initial model training.</a:t>
+              <a:t>Model accuracy depends on training data quality, and poor or imbalanced data can reduce prediction performance.</a:t>
             </a:r>
           </a:p>
           <a:p>
@@ -6957,10 +6969,13 @@
               <a:buFont typeface="Wingdings" panose="05000000000000000000" pitchFamily="2" charset="2"/>
               <a:buChar char="Ø"/>
             </a:pPr>
-            <a:endParaRPr lang="en-US" sz="2000" dirty="0">
-              <a:latin typeface="Times New Roman" panose="02020603050405020304" pitchFamily="18" charset="0"/>
-              <a:cs typeface="Times New Roman" panose="02020603050405020304" pitchFamily="18" charset="0"/>
-            </a:endParaRPr>
+            <a:r>
+              <a:rPr lang="en-US" sz="2000" dirty="0">
+                <a:latin typeface="Times New Roman" panose="02020603050405020304" pitchFamily="18" charset="0"/>
+                <a:cs typeface="Times New Roman" panose="02020603050405020304" pitchFamily="18" charset="0"/>
+              </a:rPr>
+              <a:t>Requires stable internet connectivity for continuous cloud access, real-time monitoring, and data synchronization.</a:t>
+            </a:r>
           </a:p>
           <a:p>
             <a:pPr marL="342900" indent="-342900" algn="just">
@@ -6972,18 +6987,8 @@
                 <a:latin typeface="Times New Roman" panose="02020603050405020304" pitchFamily="18" charset="0"/>
                 <a:cs typeface="Times New Roman" panose="02020603050405020304" pitchFamily="18" charset="0"/>
               </a:rPr>
-              <a:t>Continuous Connectivity Requirement: The system strictly requires stable, uninterrupted internet connectivity to facilitate continuous cloud access, real-time monitoring, and seamless data synchronization.</a:t>
-            </a:r>
-          </a:p>
-          <a:p>
-            <a:pPr marL="342900" indent="-342900" algn="just">
-              <a:buFont typeface="Wingdings" panose="05000000000000000000" pitchFamily="2" charset="2"/>
-              <a:buChar char="Ø"/>
-            </a:pPr>
-            <a:endParaRPr lang="en-US" sz="2000" dirty="0">
-              <a:latin typeface="Times New Roman" panose="02020603050405020304" pitchFamily="18" charset="0"/>
-              <a:cs typeface="Times New Roman" panose="02020603050405020304" pitchFamily="18" charset="0"/>
-            </a:endParaRPr>
+              <a:t>Needs periodic model retraining to adapt to new failure patterns, changing equipment behavior, and updated operational conditions.</a:t>
+            </a:r>
           </a:p>
         </p:txBody>
       </p:sp>
@@ -7724,7 +7729,7 @@
                 <a:latin typeface="Times New Roman" panose="02020603050405020304" pitchFamily="18" charset="0"/>
                 <a:cs typeface="Times New Roman" panose="02020603050405020304" pitchFamily="18" charset="0"/>
               </a:rPr>
-              <a:t>The Flaws of Reactive Maintenance: Heavy reliance on traditional maintenance—repairing equipment only after it fails—results in unexpected breakdowns, significant production losses, high repair costs, and increased safety risks.</a:t>
+              <a:t>Unexpected equipment failures cause production loss, downtime, and high maintenance costs in many industries.</a:t>
             </a:r>
           </a:p>
           <a:p>
@@ -7732,10 +7737,41 @@
               <a:buFont typeface="Wingdings" panose="05000000000000000000" pitchFamily="2" charset="2"/>
               <a:buChar char="ü"/>
             </a:pPr>
-            <a:endParaRPr lang="en-US" sz="2000" dirty="0">
-              <a:latin typeface="Times New Roman" panose="02020603050405020304" pitchFamily="18" charset="0"/>
-              <a:cs typeface="Times New Roman" panose="02020603050405020304" pitchFamily="18" charset="0"/>
-            </a:endParaRPr>
+            <a:r>
+              <a:rPr lang="en-US" sz="2000" dirty="0">
+                <a:latin typeface="Times New Roman" panose="02020603050405020304" pitchFamily="18" charset="0"/>
+                <a:cs typeface="Times New Roman" panose="02020603050405020304" pitchFamily="18" charset="0"/>
+              </a:rPr>
+              <a:t>Traditional maintenance happens after equipment fails. This causes production </a:t>
+            </a:r>
+            <a:r>
+              <a:rPr lang="en-US" sz="2000" dirty="0" err="1">
+                <a:latin typeface="Times New Roman" panose="02020603050405020304" pitchFamily="18" charset="0"/>
+                <a:cs typeface="Times New Roman" panose="02020603050405020304" pitchFamily="18" charset="0"/>
+              </a:rPr>
+              <a:t>loss,repair</a:t>
+            </a:r>
+            <a:r>
+              <a:rPr lang="en-US" sz="2000" dirty="0">
+                <a:latin typeface="Times New Roman" panose="02020603050405020304" pitchFamily="18" charset="0"/>
+                <a:cs typeface="Times New Roman" panose="02020603050405020304" pitchFamily="18" charset="0"/>
+              </a:rPr>
+              <a:t> </a:t>
+            </a:r>
+            <a:r>
+              <a:rPr lang="en-US" sz="2000" dirty="0" err="1">
+                <a:latin typeface="Times New Roman" panose="02020603050405020304" pitchFamily="18" charset="0"/>
+                <a:cs typeface="Times New Roman" panose="02020603050405020304" pitchFamily="18" charset="0"/>
+              </a:rPr>
+              <a:t>cost,and</a:t>
+            </a:r>
+            <a:r>
+              <a:rPr lang="en-US" sz="2000" dirty="0">
+                <a:latin typeface="Times New Roman" panose="02020603050405020304" pitchFamily="18" charset="0"/>
+                <a:cs typeface="Times New Roman" panose="02020603050405020304" pitchFamily="18" charset="0"/>
+              </a:rPr>
+              <a:t> safety risk.</a:t>
+            </a:r>
           </a:p>
           <a:p>
             <a:pPr marL="342900" indent="-342900" algn="just">
@@ -7747,7 +7783,7 @@
                 <a:latin typeface="Times New Roman" panose="02020603050405020304" pitchFamily="18" charset="0"/>
                 <a:cs typeface="Times New Roman" panose="02020603050405020304" pitchFamily="18" charset="0"/>
               </a:rPr>
-              <a:t>Operational Bottlenecks Without Analytics: The absence of intelligent analytics makes it extremely difficult for industries to optimize their maintenance planning, efficiently allocate resources, and manage spare parts effectively.</a:t>
+              <a:t>A smart system that uses analytics and cloud computing to continuously monitor equipment health and anticipate failures early is required.</a:t>
             </a:r>
           </a:p>
           <a:p>
@@ -7755,10 +7791,13 @@
               <a:buFont typeface="Wingdings" panose="05000000000000000000" pitchFamily="2" charset="2"/>
               <a:buChar char="ü"/>
             </a:pPr>
-            <a:endParaRPr lang="en-US" sz="2000" dirty="0">
-              <a:latin typeface="Times New Roman" panose="02020603050405020304" pitchFamily="18" charset="0"/>
-              <a:cs typeface="Times New Roman" panose="02020603050405020304" pitchFamily="18" charset="0"/>
-            </a:endParaRPr>
+            <a:r>
+              <a:rPr lang="en-US" sz="2000" dirty="0">
+                <a:latin typeface="Times New Roman" panose="02020603050405020304" pitchFamily="18" charset="0"/>
+                <a:cs typeface="Times New Roman" panose="02020603050405020304" pitchFamily="18" charset="0"/>
+              </a:rPr>
+              <a:t>Without intelligent analytics, industries struggle to optimize maintenance planning, resource allocation, and spare part management.</a:t>
+            </a:r>
           </a:p>
           <a:p>
             <a:pPr marL="342900" indent="-342900" algn="just">
@@ -7770,7 +7809,7 @@
                 <a:latin typeface="Times New Roman" panose="02020603050405020304" pitchFamily="18" charset="0"/>
                 <a:cs typeface="Times New Roman" panose="02020603050405020304" pitchFamily="18" charset="0"/>
               </a:rPr>
-              <a:t>The Need for Proactive Systems: To prevent unexpected failures, industries require a smart system powered by cloud computing and analytics to continuously monitor equipment health and anticipate issues early.</a:t>
+              <a:t>The absence of centralized cloud-based data storage limits historical data analysis and prevents data-driven maintenance decision-making.</a:t>
             </a:r>
           </a:p>
         </p:txBody>
@@ -7907,7 +7946,7 @@
         <p:spPr>
           <a:xfrm>
             <a:off x="265471" y="792624"/>
-            <a:ext cx="11661058" cy="3139321"/>
+            <a:ext cx="11661058" cy="4401205"/>
           </a:xfrm>
           <a:prstGeom prst="rect">
             <a:avLst/>
@@ -7920,85 +7959,94 @@
           </a:bodyPr>
           <a:lstStyle/>
           <a:p>
-            <a:pPr marL="285750" indent="-285750" algn="just">
+            <a:pPr marL="342900" indent="-342900" algn="just">
               <a:buFont typeface="Wingdings" panose="05000000000000000000" pitchFamily="2" charset="2"/>
               <a:buChar char="Ø"/>
             </a:pPr>
             <a:r>
-              <a:rPr lang="en-US" dirty="0">
-                <a:latin typeface="Times New Roman" panose="02020603050405020304" pitchFamily="18" charset="0"/>
-                <a:cs typeface="Times New Roman" panose="02020603050405020304" pitchFamily="18" charset="0"/>
-              </a:rPr>
-              <a:t>Secure Data Collection &amp; Cloud Infrastructure: Develop a secure, cloud-based platform to continuously collect, process, and store vital equipment data (such as temperature, vibration, and load) for remote, real-time health monitoring.</a:t>
-            </a:r>
-          </a:p>
-          <a:p>
-            <a:pPr marL="285750" indent="-285750" algn="just">
+              <a:rPr lang="en-US" sz="2000" dirty="0">
+                <a:latin typeface="Times New Roman" panose="02020603050405020304" pitchFamily="18" charset="0"/>
+                <a:cs typeface="Times New Roman" panose="02020603050405020304" pitchFamily="18" charset="0"/>
+              </a:rPr>
+              <a:t>To develop a cloud-based predictive maintenance system that enables continuous monitoring and intelligent analysis of equipment performance from any location.</a:t>
+            </a:r>
+          </a:p>
+          <a:p>
+            <a:pPr marL="342900" indent="-342900" algn="just">
               <a:buFont typeface="Wingdings" panose="05000000000000000000" pitchFamily="2" charset="2"/>
               <a:buChar char="Ø"/>
             </a:pPr>
-            <a:endParaRPr lang="en-US" dirty="0">
-              <a:latin typeface="Times New Roman" panose="02020603050405020304" pitchFamily="18" charset="0"/>
-              <a:cs typeface="Times New Roman" panose="02020603050405020304" pitchFamily="18" charset="0"/>
-            </a:endParaRPr>
-          </a:p>
-          <a:p>
-            <a:pPr marL="285750" indent="-285750" algn="just">
+            <a:r>
+              <a:rPr lang="en-US" sz="2000" dirty="0">
+                <a:latin typeface="Times New Roman" panose="02020603050405020304" pitchFamily="18" charset="0"/>
+                <a:cs typeface="Times New Roman" panose="02020603050405020304" pitchFamily="18" charset="0"/>
+              </a:rPr>
+              <a:t>To collect and process motor equipment data such as temperature, vibration, and load parameters to assess operational health accurately.</a:t>
+            </a:r>
+          </a:p>
+          <a:p>
+            <a:pPr marL="342900" indent="-342900" algn="just">
               <a:buFont typeface="Wingdings" panose="05000000000000000000" pitchFamily="2" charset="2"/>
               <a:buChar char="Ø"/>
             </a:pPr>
             <a:r>
-              <a:rPr lang="en-US" dirty="0">
-                <a:latin typeface="Times New Roman" panose="02020603050405020304" pitchFamily="18" charset="0"/>
-                <a:cs typeface="Times New Roman" panose="02020603050405020304" pitchFamily="18" charset="0"/>
-              </a:rPr>
-              <a:t>Predictive Analytics &amp; Machine Learning: Apply advanced machine learning algorithms to analyze operational data, extract meaningful insights, and identify early warning signs to predict and prevent unexpected failures.</a:t>
-            </a:r>
-          </a:p>
-          <a:p>
-            <a:pPr marL="285750" indent="-285750" algn="just">
+              <a:rPr lang="en-US" sz="2000" dirty="0">
+                <a:latin typeface="Times New Roman" panose="02020603050405020304" pitchFamily="18" charset="0"/>
+                <a:cs typeface="Times New Roman" panose="02020603050405020304" pitchFamily="18" charset="0"/>
+              </a:rPr>
+              <a:t>To apply Machine Learning algorithms for failure prediction in order to identify early warning signs and prevent unexpected equipment breakdowns.</a:t>
+            </a:r>
+          </a:p>
+          <a:p>
+            <a:pPr marL="342900" indent="-342900" algn="just">
               <a:buFont typeface="Wingdings" panose="05000000000000000000" pitchFamily="2" charset="2"/>
               <a:buChar char="Ø"/>
             </a:pPr>
-            <a:endParaRPr lang="en-US" dirty="0">
-              <a:latin typeface="Times New Roman" panose="02020603050405020304" pitchFamily="18" charset="0"/>
-              <a:cs typeface="Times New Roman" panose="02020603050405020304" pitchFamily="18" charset="0"/>
-            </a:endParaRPr>
-          </a:p>
-          <a:p>
-            <a:pPr marL="285750" indent="-285750" algn="just">
+            <a:r>
+              <a:rPr lang="en-US" sz="2000" dirty="0">
+                <a:latin typeface="Times New Roman" panose="02020603050405020304" pitchFamily="18" charset="0"/>
+                <a:cs typeface="Times New Roman" panose="02020603050405020304" pitchFamily="18" charset="0"/>
+              </a:rPr>
+              <a:t>To provide a real-time monitoring dashboard that visually represents equipment status, predictions, and historical trends for better decision-making.</a:t>
+            </a:r>
+          </a:p>
+          <a:p>
+            <a:pPr marL="342900" indent="-342900" algn="just">
               <a:buFont typeface="Wingdings" panose="05000000000000000000" pitchFamily="2" charset="2"/>
               <a:buChar char="Ø"/>
             </a:pPr>
             <a:r>
-              <a:rPr lang="en-US" dirty="0">
-                <a:latin typeface="Times New Roman" panose="02020603050405020304" pitchFamily="18" charset="0"/>
-                <a:cs typeface="Times New Roman" panose="02020603050405020304" pitchFamily="18" charset="0"/>
-              </a:rPr>
-              <a:t>Real-Time Visualization: Deliver an intuitive, real-time dashboard that visually represents equipment status, predictive alerts, and historical trends to facilitate rapid, data-driven decision-making.</a:t>
-            </a:r>
-          </a:p>
-          <a:p>
-            <a:pPr marL="285750" indent="-285750" algn="just">
+              <a:rPr lang="en-US" sz="2000" dirty="0">
+                <a:latin typeface="Times New Roman" panose="02020603050405020304" pitchFamily="18" charset="0"/>
+                <a:cs typeface="Times New Roman" panose="02020603050405020304" pitchFamily="18" charset="0"/>
+              </a:rPr>
+              <a:t>To reduce downtime and maintenance costs by shifting from reactive maintenance to a proactive and predictive approach.</a:t>
+            </a:r>
+          </a:p>
+          <a:p>
+            <a:pPr marL="342900" indent="-342900" algn="just">
               <a:buFont typeface="Wingdings" panose="05000000000000000000" pitchFamily="2" charset="2"/>
               <a:buChar char="Ø"/>
             </a:pPr>
-            <a:endParaRPr lang="en-US" dirty="0">
-              <a:latin typeface="Times New Roman" panose="02020603050405020304" pitchFamily="18" charset="0"/>
-              <a:cs typeface="Times New Roman" panose="02020603050405020304" pitchFamily="18" charset="0"/>
-            </a:endParaRPr>
-          </a:p>
-          <a:p>
-            <a:pPr marL="285750" indent="-285750" algn="just">
+            <a:r>
+              <a:rPr lang="en-US" sz="2000" dirty="0">
+                <a:latin typeface="Times New Roman" panose="02020603050405020304" pitchFamily="18" charset="0"/>
+                <a:cs typeface="Times New Roman" panose="02020603050405020304" pitchFamily="18" charset="0"/>
+              </a:rPr>
+              <a:t>To securely store logs and system data ensuring data integrity, confidentiality, and easy retrieval for future analysis.</a:t>
+            </a:r>
+          </a:p>
+          <a:p>
+            <a:pPr marL="342900" indent="-342900" algn="just">
               <a:buFont typeface="Wingdings" panose="05000000000000000000" pitchFamily="2" charset="2"/>
               <a:buChar char="Ø"/>
             </a:pPr>
             <a:r>
-              <a:rPr lang="en-US" dirty="0">
-                <a:latin typeface="Times New Roman" panose="02020603050405020304" pitchFamily="18" charset="0"/>
-                <a:cs typeface="Times New Roman" panose="02020603050405020304" pitchFamily="18" charset="0"/>
-              </a:rPr>
-              <a:t>Proactive Maintenance &amp; Cost Reduction: Transition from reactive repairs to a proactive, predictive maintenance strategy, significantly reducing unexpected operational downtime and long-term maintenance costs.</a:t>
+              <a:rPr lang="en-US" sz="2000" dirty="0">
+                <a:latin typeface="Times New Roman" panose="02020603050405020304" pitchFamily="18" charset="0"/>
+                <a:cs typeface="Times New Roman" panose="02020603050405020304" pitchFamily="18" charset="0"/>
+              </a:rPr>
+              <a:t>To analyze equipment data using advanced analytics models to extract meaningful insights and improve maintenance planning.</a:t>
             </a:r>
           </a:p>
         </p:txBody>
@@ -8089,7 +8137,7 @@
         <p:spPr>
           <a:xfrm>
             <a:off x="265471" y="792624"/>
-            <a:ext cx="11661058" cy="4708981"/>
+            <a:ext cx="11661058" cy="5016758"/>
           </a:xfrm>
           <a:prstGeom prst="rect">
             <a:avLst/>
@@ -8124,7 +8172,7 @@
                 <a:latin typeface="Times New Roman" panose="02020603050405020304" pitchFamily="18" charset="0"/>
                 <a:cs typeface="Times New Roman" panose="02020603050405020304" pitchFamily="18" charset="0"/>
               </a:rPr>
-              <a:t>Real-Time IoT Monitoring &amp; Data Collection: Integrate smart sensors and industrial IoT devices to continuously track vital operational parameters—such as temperature, vibration, and load—in real time.</a:t>
+              <a:t>To track the condition of equipment in real time by continuously monitoring operational parameters such as temperature, vibration, and load.</a:t>
             </a:r>
           </a:p>
           <a:p>
@@ -8132,6 +8180,33 @@
               <a:buFont typeface="Wingdings" panose="05000000000000000000" pitchFamily="2" charset="2"/>
               <a:buChar char="ü"/>
             </a:pPr>
+            <a:r>
+              <a:rPr lang="en-US" sz="2000" dirty="0">
+                <a:latin typeface="Times New Roman" panose="02020603050405020304" pitchFamily="18" charset="0"/>
+                <a:cs typeface="Times New Roman" panose="02020603050405020304" pitchFamily="18" charset="0"/>
+              </a:rPr>
+              <a:t>To predict equipment failures before they occur using data-driven models that analyze patterns and detect early warning signs.</a:t>
+            </a:r>
+          </a:p>
+          <a:p>
+            <a:pPr marL="342900" indent="-342900" algn="just">
+              <a:buFont typeface="Wingdings" panose="05000000000000000000" pitchFamily="2" charset="2"/>
+              <a:buChar char="ü"/>
+            </a:pPr>
+            <a:r>
+              <a:rPr lang="en-US" sz="2000" dirty="0">
+                <a:latin typeface="Times New Roman" panose="02020603050405020304" pitchFamily="18" charset="0"/>
+                <a:cs typeface="Times New Roman" panose="02020603050405020304" pitchFamily="18" charset="0"/>
+              </a:rPr>
+              <a:t>To enable remote monitoring through cloud integration, allowing users to access system data and predictions from any </a:t>
+            </a:r>
+            <a:r>
+              <a:rPr lang="en-US" sz="2000" dirty="0" err="1">
+                <a:latin typeface="Times New Roman" panose="02020603050405020304" pitchFamily="18" charset="0"/>
+                <a:cs typeface="Times New Roman" panose="02020603050405020304" pitchFamily="18" charset="0"/>
+              </a:rPr>
+              <a:t>location.a</a:t>
+            </a:r>
             <a:endParaRPr lang="en-US" sz="2000" dirty="0">
               <a:latin typeface="Times New Roman" panose="02020603050405020304" pitchFamily="18" charset="0"/>
               <a:cs typeface="Times New Roman" panose="02020603050405020304" pitchFamily="18" charset="0"/>
@@ -8147,7 +8222,7 @@
                 <a:latin typeface="Times New Roman" panose="02020603050405020304" pitchFamily="18" charset="0"/>
                 <a:cs typeface="Times New Roman" panose="02020603050405020304" pitchFamily="18" charset="0"/>
               </a:rPr>
-              <a:t>Scalable Cloud Architecture &amp; Remote Access: Leverage cloud deployment to efficiently manage increasing data volumes and multiple equipment units, allowing users to monitor systems and access predictions remotely from any location.</a:t>
+              <a:t>Applicable in manufacturing industries, where continuous machine operation and preventive maintenance are critical for productivity.</a:t>
             </a:r>
           </a:p>
           <a:p>
@@ -8155,10 +8230,13 @@
               <a:buFont typeface="Wingdings" panose="05000000000000000000" pitchFamily="2" charset="2"/>
               <a:buChar char="ü"/>
             </a:pPr>
-            <a:endParaRPr lang="en-US" sz="2000" dirty="0">
-              <a:latin typeface="Times New Roman" panose="02020603050405020304" pitchFamily="18" charset="0"/>
-              <a:cs typeface="Times New Roman" panose="02020603050405020304" pitchFamily="18" charset="0"/>
-            </a:endParaRPr>
+            <a:r>
+              <a:rPr lang="en-US" sz="2000" dirty="0">
+                <a:latin typeface="Times New Roman" panose="02020603050405020304" pitchFamily="18" charset="0"/>
+                <a:cs typeface="Times New Roman" panose="02020603050405020304" pitchFamily="18" charset="0"/>
+              </a:rPr>
+              <a:t>Can be implemented in power plants and heavy machinery systems to monitor critical assets and reduce operational risks.</a:t>
+            </a:r>
           </a:p>
           <a:p>
             <a:pPr marL="342900" indent="-342900" algn="just">
@@ -8170,7 +8248,7 @@
                 <a:latin typeface="Times New Roman" panose="02020603050405020304" pitchFamily="18" charset="0"/>
                 <a:cs typeface="Times New Roman" panose="02020603050405020304" pitchFamily="18" charset="0"/>
               </a:rPr>
-              <a:t>Predictive Analytics &amp; Proactive Decision-Making: Utilize data-driven models to analyze equipment patterns, detect early warning signs, and predict failures before they occur, empowering maintenance teams with faster, proactive decision-making.</a:t>
+              <a:t>Supports cloud deployment for scalability, enabling the system to handle increasing volumes of data and multiple equipment units efficiently.</a:t>
             </a:r>
           </a:p>
           <a:p>
@@ -8178,10 +8256,13 @@
               <a:buFont typeface="Wingdings" panose="05000000000000000000" pitchFamily="2" charset="2"/>
               <a:buChar char="ü"/>
             </a:pPr>
-            <a:endParaRPr lang="en-US" sz="2000" dirty="0">
-              <a:latin typeface="Times New Roman" panose="02020603050405020304" pitchFamily="18" charset="0"/>
-              <a:cs typeface="Times New Roman" panose="02020603050405020304" pitchFamily="18" charset="0"/>
-            </a:endParaRPr>
+            <a:r>
+              <a:rPr lang="en-US" sz="2000" dirty="0">
+                <a:latin typeface="Times New Roman" panose="02020603050405020304" pitchFamily="18" charset="0"/>
+                <a:cs typeface="Times New Roman" panose="02020603050405020304" pitchFamily="18" charset="0"/>
+              </a:rPr>
+              <a:t>Enables real-time monitoring from anywhere, improving accessibility and faster decision-making for maintenance teams.</a:t>
+            </a:r>
           </a:p>
           <a:p>
             <a:pPr marL="342900" indent="-342900" algn="just">
@@ -8193,7 +8274,7 @@
                 <a:latin typeface="Times New Roman" panose="02020603050405020304" pitchFamily="18" charset="0"/>
                 <a:cs typeface="Times New Roman" panose="02020603050405020304" pitchFamily="18" charset="0"/>
               </a:rPr>
-              <a:t>Cross-Industry Application &amp; Risk Mitigation: Implement the system across manufacturing, power plants, and heavy machinery environments to maintain continuous productivity, support preventive maintenance, and reduce overall operational risks.</a:t>
+              <a:t>Can be extended with IoT integration, allowing direct connection with smart sensors and industrial devices.</a:t>
             </a:r>
           </a:p>
         </p:txBody>

</xml_diff>